<commit_message>
use jdjr's interface to get real time gold price. no need to use waydroid
</commit_message>
<xml_diff>
--- a/auto_trans.pptx
+++ b/auto_trans.pptx
@@ -11,6 +11,7 @@
     <p:sldId id="259" r:id="rId5"/>
     <p:sldId id="260" r:id="rId6"/>
     <p:sldId id="261" r:id="rId7"/>
+    <p:sldId id="262" r:id="rId8"/>
   </p:sldIdLst>
   <p:sldSz cx="12192000" cy="6858000"/>
   <p:notesSz cx="6858000" cy="9144000"/>
@@ -264,7 +265,7 @@
           <a:p>
             <a:fld id="{A339E6B3-CE36-4B21-ABD6-F2C3223377B2}" type="datetimeFigureOut">
               <a:rPr lang="zh-CN" altLang="en-US" smtClean="0"/>
-              <a:t>2025/1/15</a:t>
+              <a:t>2025/2/16</a:t>
             </a:fld>
             <a:endParaRPr lang="zh-CN" altLang="en-US"/>
           </a:p>
@@ -462,7 +463,7 @@
           <a:p>
             <a:fld id="{A339E6B3-CE36-4B21-ABD6-F2C3223377B2}" type="datetimeFigureOut">
               <a:rPr lang="zh-CN" altLang="en-US" smtClean="0"/>
-              <a:t>2025/1/15</a:t>
+              <a:t>2025/2/16</a:t>
             </a:fld>
             <a:endParaRPr lang="zh-CN" altLang="en-US"/>
           </a:p>
@@ -670,7 +671,7 @@
           <a:p>
             <a:fld id="{A339E6B3-CE36-4B21-ABD6-F2C3223377B2}" type="datetimeFigureOut">
               <a:rPr lang="zh-CN" altLang="en-US" smtClean="0"/>
-              <a:t>2025/1/15</a:t>
+              <a:t>2025/2/16</a:t>
             </a:fld>
             <a:endParaRPr lang="zh-CN" altLang="en-US"/>
           </a:p>
@@ -868,7 +869,7 @@
           <a:p>
             <a:fld id="{A339E6B3-CE36-4B21-ABD6-F2C3223377B2}" type="datetimeFigureOut">
               <a:rPr lang="zh-CN" altLang="en-US" smtClean="0"/>
-              <a:t>2025/1/15</a:t>
+              <a:t>2025/2/16</a:t>
             </a:fld>
             <a:endParaRPr lang="zh-CN" altLang="en-US"/>
           </a:p>
@@ -1143,7 +1144,7 @@
           <a:p>
             <a:fld id="{A339E6B3-CE36-4B21-ABD6-F2C3223377B2}" type="datetimeFigureOut">
               <a:rPr lang="zh-CN" altLang="en-US" smtClean="0"/>
-              <a:t>2025/1/15</a:t>
+              <a:t>2025/2/16</a:t>
             </a:fld>
             <a:endParaRPr lang="zh-CN" altLang="en-US"/>
           </a:p>
@@ -1408,7 +1409,7 @@
           <a:p>
             <a:fld id="{A339E6B3-CE36-4B21-ABD6-F2C3223377B2}" type="datetimeFigureOut">
               <a:rPr lang="zh-CN" altLang="en-US" smtClean="0"/>
-              <a:t>2025/1/15</a:t>
+              <a:t>2025/2/16</a:t>
             </a:fld>
             <a:endParaRPr lang="zh-CN" altLang="en-US"/>
           </a:p>
@@ -1820,7 +1821,7 @@
           <a:p>
             <a:fld id="{A339E6B3-CE36-4B21-ABD6-F2C3223377B2}" type="datetimeFigureOut">
               <a:rPr lang="zh-CN" altLang="en-US" smtClean="0"/>
-              <a:t>2025/1/15</a:t>
+              <a:t>2025/2/16</a:t>
             </a:fld>
             <a:endParaRPr lang="zh-CN" altLang="en-US"/>
           </a:p>
@@ -1961,7 +1962,7 @@
           <a:p>
             <a:fld id="{A339E6B3-CE36-4B21-ABD6-F2C3223377B2}" type="datetimeFigureOut">
               <a:rPr lang="zh-CN" altLang="en-US" smtClean="0"/>
-              <a:t>2025/1/15</a:t>
+              <a:t>2025/2/16</a:t>
             </a:fld>
             <a:endParaRPr lang="zh-CN" altLang="en-US"/>
           </a:p>
@@ -2074,7 +2075,7 @@
           <a:p>
             <a:fld id="{A339E6B3-CE36-4B21-ABD6-F2C3223377B2}" type="datetimeFigureOut">
               <a:rPr lang="zh-CN" altLang="en-US" smtClean="0"/>
-              <a:t>2025/1/15</a:t>
+              <a:t>2025/2/16</a:t>
             </a:fld>
             <a:endParaRPr lang="zh-CN" altLang="en-US"/>
           </a:p>
@@ -2385,7 +2386,7 @@
           <a:p>
             <a:fld id="{A339E6B3-CE36-4B21-ABD6-F2C3223377B2}" type="datetimeFigureOut">
               <a:rPr lang="zh-CN" altLang="en-US" smtClean="0"/>
-              <a:t>2025/1/15</a:t>
+              <a:t>2025/2/16</a:t>
             </a:fld>
             <a:endParaRPr lang="zh-CN" altLang="en-US"/>
           </a:p>
@@ -2673,7 +2674,7 @@
           <a:p>
             <a:fld id="{A339E6B3-CE36-4B21-ABD6-F2C3223377B2}" type="datetimeFigureOut">
               <a:rPr lang="zh-CN" altLang="en-US" smtClean="0"/>
-              <a:t>2025/1/15</a:t>
+              <a:t>2025/2/16</a:t>
             </a:fld>
             <a:endParaRPr lang="zh-CN" altLang="en-US"/>
           </a:p>
@@ -2914,7 +2915,7 @@
           <a:p>
             <a:fld id="{A339E6B3-CE36-4B21-ABD6-F2C3223377B2}" type="datetimeFigureOut">
               <a:rPr lang="zh-CN" altLang="en-US" smtClean="0"/>
-              <a:t>2025/1/15</a:t>
+              <a:t>2025/2/16</a:t>
             </a:fld>
             <a:endParaRPr lang="zh-CN" altLang="en-US"/>
           </a:p>
@@ -7435,6 +7436,436 @@
 </p:sld>
 </file>
 
+<file path=ppt/slides/slide7.xml><?xml version="1.0" encoding="utf-8"?>
+<p:sld xmlns:a="http://schemas.openxmlformats.org/drawingml/2006/main" xmlns:r="http://schemas.openxmlformats.org/officeDocument/2006/relationships" xmlns:p="http://schemas.openxmlformats.org/presentationml/2006/main">
+  <p:cSld>
+    <p:spTree>
+      <p:nvGrpSpPr>
+        <p:cNvPr id="1" name=""/>
+        <p:cNvGrpSpPr/>
+        <p:nvPr/>
+      </p:nvGrpSpPr>
+      <p:grpSpPr>
+        <a:xfrm>
+          <a:off x="0" y="0"/>
+          <a:ext cx="0" cy="0"/>
+          <a:chOff x="0" y="0"/>
+          <a:chExt cx="0" cy="0"/>
+        </a:xfrm>
+      </p:grpSpPr>
+      <p:sp>
+        <p:nvSpPr>
+          <p:cNvPr id="4" name="文本框 3">
+            <a:extLst>
+              <a:ext uri="{FF2B5EF4-FFF2-40B4-BE49-F238E27FC236}">
+                <a16:creationId xmlns:a16="http://schemas.microsoft.com/office/drawing/2014/main" id="{92E2CF0A-8164-C063-CDF8-6A500D811449}"/>
+              </a:ext>
+            </a:extLst>
+          </p:cNvPr>
+          <p:cNvSpPr txBox="1"/>
+          <p:nvPr/>
+        </p:nvSpPr>
+        <p:spPr>
+          <a:xfrm>
+            <a:off x="1095647" y="3749431"/>
+            <a:ext cx="6820444" cy="2585323"/>
+          </a:xfrm>
+          <a:prstGeom prst="rect">
+            <a:avLst/>
+          </a:prstGeom>
+          <a:noFill/>
+        </p:spPr>
+        <p:txBody>
+          <a:bodyPr wrap="square">
+            <a:spAutoFit/>
+          </a:bodyPr>
+          <a:lstStyle/>
+          <a:p>
+            <a:r>
+              <a:rPr lang="zh-CN" altLang="en-US" b="1" dirty="0">
+                <a:latin typeface="阿里巴巴普惠体 2.0 55 Regular" panose="00020600040101010101" pitchFamily="18" charset="-122"/>
+                <a:ea typeface="阿里巴巴普惠体 2.0 55 Regular" panose="00020600040101010101" pitchFamily="18" charset="-122"/>
+                <a:cs typeface="阿里巴巴普惠体 2.0 55 Regular" panose="00020600040101010101" pitchFamily="18" charset="-122"/>
+              </a:rPr>
+              <a:t>在终端里 </a:t>
+            </a:r>
+            <a:r>
+              <a:rPr lang="en-US" altLang="zh-CN" b="1" dirty="0">
+                <a:latin typeface="阿里巴巴普惠体 2.0 55 Regular" panose="00020600040101010101" pitchFamily="18" charset="-122"/>
+                <a:ea typeface="阿里巴巴普惠体 2.0 55 Regular" panose="00020600040101010101" pitchFamily="18" charset="-122"/>
+                <a:cs typeface="阿里巴巴普惠体 2.0 55 Regular" panose="00020600040101010101" pitchFamily="18" charset="-122"/>
+              </a:rPr>
+              <a:t>ping –c 4 8.8.8.8</a:t>
+            </a:r>
+            <a:r>
+              <a:rPr lang="zh-CN" altLang="en-US" b="1" dirty="0">
+                <a:latin typeface="阿里巴巴普惠体 2.0 55 Regular" panose="00020600040101010101" pitchFamily="18" charset="-122"/>
+                <a:ea typeface="阿里巴巴普惠体 2.0 55 Regular" panose="00020600040101010101" pitchFamily="18" charset="-122"/>
+                <a:cs typeface="阿里巴巴普惠体 2.0 55 Regular" panose="00020600040101010101" pitchFamily="18" charset="-122"/>
+              </a:rPr>
+              <a:t>能通</a:t>
+            </a:r>
+            <a:endParaRPr lang="en-US" altLang="zh-CN" b="1" dirty="0">
+              <a:latin typeface="阿里巴巴普惠体 2.0 55 Regular" panose="00020600040101010101" pitchFamily="18" charset="-122"/>
+              <a:ea typeface="阿里巴巴普惠体 2.0 55 Regular" panose="00020600040101010101" pitchFamily="18" charset="-122"/>
+              <a:cs typeface="阿里巴巴普惠体 2.0 55 Regular" panose="00020600040101010101" pitchFamily="18" charset="-122"/>
+            </a:endParaRPr>
+          </a:p>
+          <a:p>
+            <a:r>
+              <a:rPr lang="zh-CN" altLang="en-US" b="1" dirty="0">
+                <a:latin typeface="阿里巴巴普惠体 2.0 55 Regular" panose="00020600040101010101" pitchFamily="18" charset="-122"/>
+                <a:ea typeface="阿里巴巴普惠体 2.0 55 Regular" panose="00020600040101010101" pitchFamily="18" charset="-122"/>
+                <a:cs typeface="阿里巴巴普惠体 2.0 55 Regular" panose="00020600040101010101" pitchFamily="18" charset="-122"/>
+              </a:rPr>
+              <a:t>在</a:t>
+            </a:r>
+            <a:r>
+              <a:rPr lang="en-US" altLang="zh-CN" b="1" dirty="0" err="1">
+                <a:latin typeface="阿里巴巴普惠体 2.0 55 Regular" panose="00020600040101010101" pitchFamily="18" charset="-122"/>
+                <a:ea typeface="阿里巴巴普惠体 2.0 55 Regular" panose="00020600040101010101" pitchFamily="18" charset="-122"/>
+                <a:cs typeface="阿里巴巴普惠体 2.0 55 Regular" panose="00020600040101010101" pitchFamily="18" charset="-122"/>
+              </a:rPr>
+              <a:t>sudo</a:t>
+            </a:r>
+            <a:r>
+              <a:rPr lang="en-US" altLang="zh-CN" b="1" dirty="0">
+                <a:latin typeface="阿里巴巴普惠体 2.0 55 Regular" panose="00020600040101010101" pitchFamily="18" charset="-122"/>
+                <a:ea typeface="阿里巴巴普惠体 2.0 55 Regular" panose="00020600040101010101" pitchFamily="18" charset="-122"/>
+                <a:cs typeface="阿里巴巴普惠体 2.0 55 Regular" panose="00020600040101010101" pitchFamily="18" charset="-122"/>
+              </a:rPr>
+              <a:t> </a:t>
+            </a:r>
+            <a:r>
+              <a:rPr lang="en-US" altLang="zh-CN" b="1" dirty="0" err="1">
+                <a:latin typeface="阿里巴巴普惠体 2.0 55 Regular" panose="00020600040101010101" pitchFamily="18" charset="-122"/>
+                <a:ea typeface="阿里巴巴普惠体 2.0 55 Regular" panose="00020600040101010101" pitchFamily="18" charset="-122"/>
+                <a:cs typeface="阿里巴巴普惠体 2.0 55 Regular" panose="00020600040101010101" pitchFamily="18" charset="-122"/>
+              </a:rPr>
+              <a:t>waydroid</a:t>
+            </a:r>
+            <a:r>
+              <a:rPr lang="en-US" altLang="zh-CN" b="1" dirty="0">
+                <a:latin typeface="阿里巴巴普惠体 2.0 55 Regular" panose="00020600040101010101" pitchFamily="18" charset="-122"/>
+                <a:ea typeface="阿里巴巴普惠体 2.0 55 Regular" panose="00020600040101010101" pitchFamily="18" charset="-122"/>
+                <a:cs typeface="阿里巴巴普惠体 2.0 55 Regular" panose="00020600040101010101" pitchFamily="18" charset="-122"/>
+              </a:rPr>
+              <a:t> shell</a:t>
+            </a:r>
+            <a:r>
+              <a:rPr lang="zh-CN" altLang="en-US" b="1" dirty="0">
+                <a:latin typeface="阿里巴巴普惠体 2.0 55 Regular" panose="00020600040101010101" pitchFamily="18" charset="-122"/>
+                <a:ea typeface="阿里巴巴普惠体 2.0 55 Regular" panose="00020600040101010101" pitchFamily="18" charset="-122"/>
+                <a:cs typeface="阿里巴巴普惠体 2.0 55 Regular" panose="00020600040101010101" pitchFamily="18" charset="-122"/>
+              </a:rPr>
+              <a:t>里 </a:t>
+            </a:r>
+            <a:r>
+              <a:rPr lang="en-US" altLang="zh-CN" b="1" dirty="0">
+                <a:latin typeface="阿里巴巴普惠体 2.0 55 Regular" panose="00020600040101010101" pitchFamily="18" charset="-122"/>
+                <a:ea typeface="阿里巴巴普惠体 2.0 55 Regular" panose="00020600040101010101" pitchFamily="18" charset="-122"/>
+                <a:cs typeface="阿里巴巴普惠体 2.0 55 Regular" panose="00020600040101010101" pitchFamily="18" charset="-122"/>
+              </a:rPr>
+              <a:t>curl –I </a:t>
+            </a:r>
+            <a:r>
+              <a:rPr lang="en-US" altLang="zh-CN" b="1" dirty="0">
+                <a:latin typeface="阿里巴巴普惠体 2.0 55 Regular" panose="00020600040101010101" pitchFamily="18" charset="-122"/>
+                <a:ea typeface="阿里巴巴普惠体 2.0 55 Regular" panose="00020600040101010101" pitchFamily="18" charset="-122"/>
+                <a:cs typeface="阿里巴巴普惠体 2.0 55 Regular" panose="00020600040101010101" pitchFamily="18" charset="-122"/>
+                <a:hlinkClick r:id="rId2"/>
+              </a:rPr>
+              <a:t>https://Baidu.com</a:t>
+            </a:r>
+            <a:r>
+              <a:rPr lang="zh-CN" altLang="en-US" b="1" dirty="0">
+                <a:latin typeface="阿里巴巴普惠体 2.0 55 Regular" panose="00020600040101010101" pitchFamily="18" charset="-122"/>
+                <a:ea typeface="阿里巴巴普惠体 2.0 55 Regular" panose="00020600040101010101" pitchFamily="18" charset="-122"/>
+                <a:cs typeface="阿里巴巴普惠体 2.0 55 Regular" panose="00020600040101010101" pitchFamily="18" charset="-122"/>
+              </a:rPr>
+              <a:t>也能通</a:t>
+            </a:r>
+            <a:endParaRPr lang="en-US" altLang="zh-CN" b="1" dirty="0">
+              <a:latin typeface="阿里巴巴普惠体 2.0 55 Regular" panose="00020600040101010101" pitchFamily="18" charset="-122"/>
+              <a:ea typeface="阿里巴巴普惠体 2.0 55 Regular" panose="00020600040101010101" pitchFamily="18" charset="-122"/>
+              <a:cs typeface="阿里巴巴普惠体 2.0 55 Regular" panose="00020600040101010101" pitchFamily="18" charset="-122"/>
+            </a:endParaRPr>
+          </a:p>
+          <a:p>
+            <a:endParaRPr lang="en-US" altLang="zh-CN" b="1" dirty="0">
+              <a:latin typeface="阿里巴巴普惠体 2.0 55 Regular" panose="00020600040101010101" pitchFamily="18" charset="-122"/>
+              <a:ea typeface="阿里巴巴普惠体 2.0 55 Regular" panose="00020600040101010101" pitchFamily="18" charset="-122"/>
+              <a:cs typeface="阿里巴巴普惠体 2.0 55 Regular" panose="00020600040101010101" pitchFamily="18" charset="-122"/>
+            </a:endParaRPr>
+          </a:p>
+          <a:p>
+            <a:r>
+              <a:rPr lang="zh-CN" altLang="en-US" b="1" dirty="0">
+                <a:latin typeface="阿里巴巴普惠体 2.0 55 Regular" panose="00020600040101010101" pitchFamily="18" charset="-122"/>
+                <a:ea typeface="阿里巴巴普惠体 2.0 55 Regular" panose="00020600040101010101" pitchFamily="18" charset="-122"/>
+                <a:cs typeface="阿里巴巴普惠体 2.0 55 Regular" panose="00020600040101010101" pitchFamily="18" charset="-122"/>
+              </a:rPr>
+              <a:t>但是在</a:t>
+            </a:r>
+            <a:r>
+              <a:rPr lang="en-US" altLang="zh-CN" b="1" dirty="0" err="1">
+                <a:latin typeface="阿里巴巴普惠体 2.0 55 Regular" panose="00020600040101010101" pitchFamily="18" charset="-122"/>
+                <a:ea typeface="阿里巴巴普惠体 2.0 55 Regular" panose="00020600040101010101" pitchFamily="18" charset="-122"/>
+                <a:cs typeface="阿里巴巴普惠体 2.0 55 Regular" panose="00020600040101010101" pitchFamily="18" charset="-122"/>
+              </a:rPr>
+              <a:t>ui</a:t>
+            </a:r>
+            <a:r>
+              <a:rPr lang="zh-CN" altLang="en-US" b="1" dirty="0">
+                <a:latin typeface="阿里巴巴普惠体 2.0 55 Regular" panose="00020600040101010101" pitchFamily="18" charset="-122"/>
+                <a:ea typeface="阿里巴巴普惠体 2.0 55 Regular" panose="00020600040101010101" pitchFamily="18" charset="-122"/>
+                <a:cs typeface="阿里巴巴普惠体 2.0 55 Regular" panose="00020600040101010101" pitchFamily="18" charset="-122"/>
+              </a:rPr>
+              <a:t>里连不上网</a:t>
+            </a:r>
+            <a:endParaRPr lang="en-US" altLang="zh-CN" b="1" dirty="0">
+              <a:latin typeface="阿里巴巴普惠体 2.0 55 Regular" panose="00020600040101010101" pitchFamily="18" charset="-122"/>
+              <a:ea typeface="阿里巴巴普惠体 2.0 55 Regular" panose="00020600040101010101" pitchFamily="18" charset="-122"/>
+              <a:cs typeface="阿里巴巴普惠体 2.0 55 Regular" panose="00020600040101010101" pitchFamily="18" charset="-122"/>
+            </a:endParaRPr>
+          </a:p>
+          <a:p>
+            <a:endParaRPr lang="en-US" altLang="zh-CN" b="1" dirty="0">
+              <a:latin typeface="阿里巴巴普惠体 2.0 55 Regular" panose="00020600040101010101" pitchFamily="18" charset="-122"/>
+              <a:ea typeface="阿里巴巴普惠体 2.0 55 Regular" panose="00020600040101010101" pitchFamily="18" charset="-122"/>
+              <a:cs typeface="阿里巴巴普惠体 2.0 55 Regular" panose="00020600040101010101" pitchFamily="18" charset="-122"/>
+            </a:endParaRPr>
+          </a:p>
+          <a:p>
+            <a:r>
+              <a:rPr lang="zh-CN" altLang="en-US" b="1" dirty="0">
+                <a:latin typeface="阿里巴巴普惠体 2.0 55 Regular" panose="00020600040101010101" pitchFamily="18" charset="-122"/>
+                <a:ea typeface="阿里巴巴普惠体 2.0 55 Regular" panose="00020600040101010101" pitchFamily="18" charset="-122"/>
+                <a:cs typeface="阿里巴巴普惠体 2.0 55 Regular" panose="00020600040101010101" pitchFamily="18" charset="-122"/>
+              </a:rPr>
+              <a:t>本次是 </a:t>
+            </a:r>
+            <a:r>
+              <a:rPr lang="en-US" altLang="zh-CN" b="1" dirty="0" err="1">
+                <a:latin typeface="阿里巴巴普惠体 2.0 55 Regular" panose="00020600040101010101" pitchFamily="18" charset="-122"/>
+                <a:ea typeface="阿里巴巴普惠体 2.0 55 Regular" panose="00020600040101010101" pitchFamily="18" charset="-122"/>
+                <a:cs typeface="阿里巴巴普惠体 2.0 55 Regular" panose="00020600040101010101" pitchFamily="18" charset="-122"/>
+              </a:rPr>
+              <a:t>sudo</a:t>
+            </a:r>
+            <a:r>
+              <a:rPr lang="en-US" altLang="zh-CN" b="1" dirty="0">
+                <a:latin typeface="阿里巴巴普惠体 2.0 55 Regular" panose="00020600040101010101" pitchFamily="18" charset="-122"/>
+                <a:ea typeface="阿里巴巴普惠体 2.0 55 Regular" panose="00020600040101010101" pitchFamily="18" charset="-122"/>
+                <a:cs typeface="阿里巴巴普惠体 2.0 55 Regular" panose="00020600040101010101" pitchFamily="18" charset="-122"/>
+              </a:rPr>
+              <a:t> </a:t>
+            </a:r>
+            <a:r>
+              <a:rPr lang="en-US" altLang="zh-CN" b="1" dirty="0" err="1">
+                <a:latin typeface="阿里巴巴普惠体 2.0 55 Regular" panose="00020600040101010101" pitchFamily="18" charset="-122"/>
+                <a:ea typeface="阿里巴巴普惠体 2.0 55 Regular" panose="00020600040101010101" pitchFamily="18" charset="-122"/>
+                <a:cs typeface="阿里巴巴普惠体 2.0 55 Regular" panose="00020600040101010101" pitchFamily="18" charset="-122"/>
+              </a:rPr>
+              <a:t>waydroid</a:t>
+            </a:r>
+            <a:r>
+              <a:rPr lang="en-US" altLang="zh-CN" b="1" dirty="0">
+                <a:latin typeface="阿里巴巴普惠体 2.0 55 Regular" panose="00020600040101010101" pitchFamily="18" charset="-122"/>
+                <a:ea typeface="阿里巴巴普惠体 2.0 55 Regular" panose="00020600040101010101" pitchFamily="18" charset="-122"/>
+                <a:cs typeface="阿里巴巴普惠体 2.0 55 Regular" panose="00020600040101010101" pitchFamily="18" charset="-122"/>
+              </a:rPr>
+              <a:t> </a:t>
+            </a:r>
+            <a:r>
+              <a:rPr lang="en-US" altLang="zh-CN" b="1" dirty="0" err="1">
+                <a:latin typeface="阿里巴巴普惠体 2.0 55 Regular" panose="00020600040101010101" pitchFamily="18" charset="-122"/>
+                <a:ea typeface="阿里巴巴普惠体 2.0 55 Regular" panose="00020600040101010101" pitchFamily="18" charset="-122"/>
+                <a:cs typeface="阿里巴巴普惠体 2.0 55 Regular" panose="00020600040101010101" pitchFamily="18" charset="-122"/>
+              </a:rPr>
+              <a:t>init</a:t>
+            </a:r>
+            <a:r>
+              <a:rPr lang="en-US" altLang="zh-CN" b="1" dirty="0">
+                <a:latin typeface="阿里巴巴普惠体 2.0 55 Regular" panose="00020600040101010101" pitchFamily="18" charset="-122"/>
+                <a:ea typeface="阿里巴巴普惠体 2.0 55 Regular" panose="00020600040101010101" pitchFamily="18" charset="-122"/>
+                <a:cs typeface="阿里巴巴普惠体 2.0 55 Regular" panose="00020600040101010101" pitchFamily="18" charset="-122"/>
+              </a:rPr>
+              <a:t> –f</a:t>
+            </a:r>
+            <a:r>
+              <a:rPr lang="zh-CN" altLang="en-US" b="1" dirty="0">
+                <a:latin typeface="阿里巴巴普惠体 2.0 55 Regular" panose="00020600040101010101" pitchFamily="18" charset="-122"/>
+                <a:ea typeface="阿里巴巴普惠体 2.0 55 Regular" panose="00020600040101010101" pitchFamily="18" charset="-122"/>
+                <a:cs typeface="阿里巴巴普惠体 2.0 55 Regular" panose="00020600040101010101" pitchFamily="18" charset="-122"/>
+              </a:rPr>
+              <a:t>后</a:t>
+            </a:r>
+            <a:r>
+              <a:rPr lang="en-US" altLang="zh-CN" b="1" dirty="0" err="1">
+                <a:latin typeface="阿里巴巴普惠体 2.0 55 Regular" panose="00020600040101010101" pitchFamily="18" charset="-122"/>
+                <a:ea typeface="阿里巴巴普惠体 2.0 55 Regular" panose="00020600040101010101" pitchFamily="18" charset="-122"/>
+                <a:cs typeface="阿里巴巴普惠体 2.0 55 Regular" panose="00020600040101010101" pitchFamily="18" charset="-122"/>
+              </a:rPr>
+              <a:t>sudo</a:t>
+            </a:r>
+            <a:r>
+              <a:rPr lang="en-US" altLang="zh-CN" b="1" dirty="0">
+                <a:latin typeface="阿里巴巴普惠体 2.0 55 Regular" panose="00020600040101010101" pitchFamily="18" charset="-122"/>
+                <a:ea typeface="阿里巴巴普惠体 2.0 55 Regular" panose="00020600040101010101" pitchFamily="18" charset="-122"/>
+                <a:cs typeface="阿里巴巴普惠体 2.0 55 Regular" panose="00020600040101010101" pitchFamily="18" charset="-122"/>
+              </a:rPr>
+              <a:t> </a:t>
+            </a:r>
+            <a:r>
+              <a:rPr lang="en-US" altLang="zh-CN" b="1" dirty="0" err="1">
+                <a:latin typeface="阿里巴巴普惠体 2.0 55 Regular" panose="00020600040101010101" pitchFamily="18" charset="-122"/>
+                <a:ea typeface="阿里巴巴普惠体 2.0 55 Regular" panose="00020600040101010101" pitchFamily="18" charset="-122"/>
+                <a:cs typeface="阿里巴巴普惠体 2.0 55 Regular" panose="00020600040101010101" pitchFamily="18" charset="-122"/>
+              </a:rPr>
+              <a:t>systemctl</a:t>
+            </a:r>
+            <a:r>
+              <a:rPr lang="en-US" altLang="zh-CN" b="1" dirty="0">
+                <a:latin typeface="阿里巴巴普惠体 2.0 55 Regular" panose="00020600040101010101" pitchFamily="18" charset="-122"/>
+                <a:ea typeface="阿里巴巴普惠体 2.0 55 Regular" panose="00020600040101010101" pitchFamily="18" charset="-122"/>
+                <a:cs typeface="阿里巴巴普惠体 2.0 55 Regular" panose="00020600040101010101" pitchFamily="18" charset="-122"/>
+              </a:rPr>
+              <a:t> start </a:t>
+            </a:r>
+            <a:r>
+              <a:rPr lang="en-US" altLang="zh-CN" b="1" dirty="0" err="1">
+                <a:latin typeface="阿里巴巴普惠体 2.0 55 Regular" panose="00020600040101010101" pitchFamily="18" charset="-122"/>
+                <a:ea typeface="阿里巴巴普惠体 2.0 55 Regular" panose="00020600040101010101" pitchFamily="18" charset="-122"/>
+                <a:cs typeface="阿里巴巴普惠体 2.0 55 Regular" panose="00020600040101010101" pitchFamily="18" charset="-122"/>
+              </a:rPr>
+              <a:t>waydroid</a:t>
+            </a:r>
+            <a:r>
+              <a:rPr lang="en-US" altLang="zh-CN" b="1" dirty="0">
+                <a:latin typeface="阿里巴巴普惠体 2.0 55 Regular" panose="00020600040101010101" pitchFamily="18" charset="-122"/>
+                <a:ea typeface="阿里巴巴普惠体 2.0 55 Regular" panose="00020600040101010101" pitchFamily="18" charset="-122"/>
+                <a:cs typeface="阿里巴巴普惠体 2.0 55 Regular" panose="00020600040101010101" pitchFamily="18" charset="-122"/>
+              </a:rPr>
+              <a:t>-container</a:t>
+            </a:r>
+            <a:r>
+              <a:rPr lang="zh-CN" altLang="en-US" b="1" dirty="0">
+                <a:latin typeface="阿里巴巴普惠体 2.0 55 Regular" panose="00020600040101010101" pitchFamily="18" charset="-122"/>
+                <a:ea typeface="阿里巴巴普惠体 2.0 55 Regular" panose="00020600040101010101" pitchFamily="18" charset="-122"/>
+                <a:cs typeface="阿里巴巴普惠体 2.0 55 Regular" panose="00020600040101010101" pitchFamily="18" charset="-122"/>
+              </a:rPr>
+              <a:t>和</a:t>
+            </a:r>
+            <a:r>
+              <a:rPr lang="en-US" altLang="zh-CN" b="1" dirty="0" err="1">
+                <a:latin typeface="阿里巴巴普惠体 2.0 55 Regular" panose="00020600040101010101" pitchFamily="18" charset="-122"/>
+                <a:ea typeface="阿里巴巴普惠体 2.0 55 Regular" panose="00020600040101010101" pitchFamily="18" charset="-122"/>
+                <a:cs typeface="阿里巴巴普惠体 2.0 55 Regular" panose="00020600040101010101" pitchFamily="18" charset="-122"/>
+              </a:rPr>
+              <a:t>waydroid</a:t>
+            </a:r>
+            <a:r>
+              <a:rPr lang="en-US" altLang="zh-CN" b="1" dirty="0">
+                <a:latin typeface="阿里巴巴普惠体 2.0 55 Regular" panose="00020600040101010101" pitchFamily="18" charset="-122"/>
+                <a:ea typeface="阿里巴巴普惠体 2.0 55 Regular" panose="00020600040101010101" pitchFamily="18" charset="-122"/>
+                <a:cs typeface="阿里巴巴普惠体 2.0 55 Regular" panose="00020600040101010101" pitchFamily="18" charset="-122"/>
+              </a:rPr>
+              <a:t> session start</a:t>
+            </a:r>
+            <a:r>
+              <a:rPr lang="zh-CN" altLang="en-US" b="1" dirty="0">
+                <a:latin typeface="阿里巴巴普惠体 2.0 55 Regular" panose="00020600040101010101" pitchFamily="18" charset="-122"/>
+                <a:ea typeface="阿里巴巴普惠体 2.0 55 Regular" panose="00020600040101010101" pitchFamily="18" charset="-122"/>
+                <a:cs typeface="阿里巴巴普惠体 2.0 55 Regular" panose="00020600040101010101" pitchFamily="18" charset="-122"/>
+              </a:rPr>
+              <a:t>就好了</a:t>
+            </a:r>
+            <a:endParaRPr lang="en-US" altLang="zh-CN" b="1" dirty="0">
+              <a:latin typeface="阿里巴巴普惠体 2.0 55 Regular" panose="00020600040101010101" pitchFamily="18" charset="-122"/>
+              <a:ea typeface="阿里巴巴普惠体 2.0 55 Regular" panose="00020600040101010101" pitchFamily="18" charset="-122"/>
+              <a:cs typeface="阿里巴巴普惠体 2.0 55 Regular" panose="00020600040101010101" pitchFamily="18" charset="-122"/>
+            </a:endParaRPr>
+          </a:p>
+          <a:p>
+            <a:endParaRPr lang="en-US" altLang="zh-CN" b="1" dirty="0">
+              <a:latin typeface="阿里巴巴普惠体 2.0 55 Regular" panose="00020600040101010101" pitchFamily="18" charset="-122"/>
+              <a:ea typeface="阿里巴巴普惠体 2.0 55 Regular" panose="00020600040101010101" pitchFamily="18" charset="-122"/>
+              <a:cs typeface="阿里巴巴普惠体 2.0 55 Regular" panose="00020600040101010101" pitchFamily="18" charset="-122"/>
+            </a:endParaRPr>
+          </a:p>
+          <a:p>
+            <a:r>
+              <a:rPr lang="zh-CN" altLang="en-US" b="1" dirty="0">
+                <a:solidFill>
+                  <a:srgbClr val="FF0000"/>
+                </a:solidFill>
+                <a:latin typeface="阿里巴巴普惠体 2.0 55 Regular" panose="00020600040101010101" pitchFamily="18" charset="-122"/>
+                <a:ea typeface="阿里巴巴普惠体 2.0 55 Regular" panose="00020600040101010101" pitchFamily="18" charset="-122"/>
+                <a:cs typeface="阿里巴巴普惠体 2.0 55 Regular" panose="00020600040101010101" pitchFamily="18" charset="-122"/>
+              </a:rPr>
+              <a:t>破案了，原来是家里</a:t>
+            </a:r>
+            <a:r>
+              <a:rPr lang="en-US" altLang="zh-CN" b="1" dirty="0">
+                <a:solidFill>
+                  <a:srgbClr val="FF0000"/>
+                </a:solidFill>
+                <a:latin typeface="阿里巴巴普惠体 2.0 55 Regular" panose="00020600040101010101" pitchFamily="18" charset="-122"/>
+                <a:ea typeface="阿里巴巴普惠体 2.0 55 Regular" panose="00020600040101010101" pitchFamily="18" charset="-122"/>
+                <a:cs typeface="阿里巴巴普惠体 2.0 55 Regular" panose="00020600040101010101" pitchFamily="18" charset="-122"/>
+              </a:rPr>
+              <a:t>E0DO</a:t>
+            </a:r>
+            <a:r>
+              <a:rPr lang="zh-CN" altLang="en-US" b="1" dirty="0">
+                <a:solidFill>
+                  <a:srgbClr val="FF0000"/>
+                </a:solidFill>
+                <a:latin typeface="阿里巴巴普惠体 2.0 55 Regular" panose="00020600040101010101" pitchFamily="18" charset="-122"/>
+                <a:ea typeface="阿里巴巴普惠体 2.0 55 Regular" panose="00020600040101010101" pitchFamily="18" charset="-122"/>
+                <a:cs typeface="阿里巴巴普惠体 2.0 55 Regular" panose="00020600040101010101" pitchFamily="18" charset="-122"/>
+              </a:rPr>
+              <a:t>的</a:t>
+            </a:r>
+            <a:r>
+              <a:rPr lang="en-US" altLang="zh-CN" b="1" dirty="0" err="1">
+                <a:solidFill>
+                  <a:srgbClr val="FF0000"/>
+                </a:solidFill>
+                <a:latin typeface="阿里巴巴普惠体 2.0 55 Regular" panose="00020600040101010101" pitchFamily="18" charset="-122"/>
+                <a:ea typeface="阿里巴巴普惠体 2.0 55 Regular" panose="00020600040101010101" pitchFamily="18" charset="-122"/>
+                <a:cs typeface="阿里巴巴普惠体 2.0 55 Regular" panose="00020600040101010101" pitchFamily="18" charset="-122"/>
+              </a:rPr>
+              <a:t>WiFi</a:t>
+            </a:r>
+            <a:r>
+              <a:rPr lang="zh-CN" altLang="en-US" b="1" dirty="0">
+                <a:solidFill>
+                  <a:srgbClr val="FF0000"/>
+                </a:solidFill>
+                <a:latin typeface="阿里巴巴普惠体 2.0 55 Regular" panose="00020600040101010101" pitchFamily="18" charset="-122"/>
+                <a:ea typeface="阿里巴巴普惠体 2.0 55 Regular" panose="00020600040101010101" pitchFamily="18" charset="-122"/>
+                <a:cs typeface="阿里巴巴普惠体 2.0 55 Regular" panose="00020600040101010101" pitchFamily="18" charset="-122"/>
+              </a:rPr>
+              <a:t>有问题</a:t>
+            </a:r>
+          </a:p>
+        </p:txBody>
+      </p:sp>
+    </p:spTree>
+    <p:extLst>
+      <p:ext uri="{BB962C8B-B14F-4D97-AF65-F5344CB8AC3E}">
+        <p14:creationId xmlns:p14="http://schemas.microsoft.com/office/powerpoint/2010/main" val="3401268345"/>
+      </p:ext>
+    </p:extLst>
+  </p:cSld>
+  <p:clrMapOvr>
+    <a:masterClrMapping/>
+  </p:clrMapOvr>
+</p:sld>
+</file>
+
 <file path=ppt/theme/theme1.xml><?xml version="1.0" encoding="utf-8"?>
 <a:theme xmlns:a="http://schemas.openxmlformats.org/drawingml/2006/main" name="Office 主题​​">
   <a:themeElements>

</xml_diff>